<commit_message>
PPT V11 with final-method manifest result; archive v9.1 manifest run; learning curve with fragments
</commit_message>
<xml_diff>
--- a/docs/reports/group_meeting_deck_2026-10-16-en-v11/V11-Long-term memory for a small website generator.pptx
+++ b/docs/reports/group_meeting_deck_2026-10-16-en-v11/V11-Long-term memory for a small website generator.pptx
@@ -471,7 +471,7 @@
           <a:lstStyle/>
           <a:p>
             <a:r>
-              <a:t>Our versions fall into three families. Text memory gives lessons as text; the small model mostly ignores them: 30.9 percent. Code memory adds short code examples from our own working sites: 40 percent. The final version uses only checked fragments, never whole files. And the checklist alone, without memory, helps only a little.</a:t>
+              <a:t>We tried many versions, but they fall into three families, and from now on I only use these three names. Text memory gives the model lessons written as text; its last version adds a checklist. The text piles up and the small model ignores it: 30.9 percent. Code memory keeps the checklist and adds short code examples from our own working sites: this is the big jump, to 40 percent. The final version changes only how examples are chosen: only checked fragments, never a whole file, which matters when the task order changes. The last row is an ablation: the checklist alone, with memory turned off, helps only a little.</a:t>
             </a:r>
           </a:p>
         </p:txBody>
@@ -553,7 +553,7 @@
           <a:p>
             <a:r>
               <a:rPr dirty="0"/>
-              <a:t>The main result. Without memory: 28.5 percent and 30 zero-score tasks. With whole-file code memory: 40 percent and 13. Paired by task, the gain is 11.5 points, and the 95 percent confidence interval, 6 to 16.9, does not include zero.</a:t>
+              <a:t>The main result. Without memory: 28.5 percent and 30 zero-score tasks. With whole-file code memory: 40 percent and 13. Paired by task, the gain is 11.5 points, and the 95 percent confidence interval, 6 to 16.9, does not include zero. The final method with fragments reaches 35.2 percent, a gain of 7.1 points with interval 0.9 to 13.1, lower than whole-file in this order because vue-router imports came back.</a:t>
             </a:r>
           </a:p>
         </p:txBody>
@@ -725,7 +725,7 @@
           <a:lstStyle/>
           <a:p>
             <a:r>
-              <a:t>The ablation adds one part at a time. The checklist alone adds 3.4 points, and its interval includes zero. Adding memory on top adds 8.1 points, and its interval excludes zero. So most of the gain comes from memory.</a:t>
+              <a:t>The ablation adds one part at a time. The checklist alone adds 3.4 points, and this is not significant. Adding memory on top adds 8.1 points, and this is significant. So most of the gain comes from memory.</a:t>
             </a:r>
           </a:p>
         </p:txBody>
@@ -812,7 +812,7 @@
           <a:p>
             <a:r>
               <a:rPr dirty="0"/>
-              <a:t>With memory, order matters, because each task only sees earlier ones. In two shuffled orders, whole-file code memory gained only about 4.5 points: one whole-file example was copied as a finished answer, giving the empty starter project. With fragments only, the gain is 7.4 points on seed 11, where the interval excludes zero, and 5.5 on seed 29.</a:t>
+              <a:t>With memory, the task order matters, because each task can only use what came before it. We tried two shuffled orders. With whole-file code memory the gain dropped to about four and a half points. The reason: one code example was a whole file, and the model copied it as a finished answer, returning the empty starter project. In the fragment version every example is a short checked fragment. Blank sites go to zero, and the gain is 7.4 points on seed 11, which is significant, and 5.5 on seed 29. The chart shows the gap staying near or above zero.</a:t>
             </a:r>
           </a:p>
         </p:txBody>
@@ -1410,7 +1410,7 @@
           <a:lstStyle/>
           <a:p>
             <a:r>
-              <a:t>The generator is WebGen-LM-7B: Qwen2.5-Coder-7B fine-tuned by the benchmark authors on Bolt trajectories, so it already knows Bolt's format. Everything is self-hosted on two H200 GPUs on the school cluster, with no paid API. One task takes about twelve minutes with memory.</a:t>
+              <a:t>Before the results, a word on the models and compute. The generator is WebGen-LM-7B. It is not a general Qwen model: the WebGen-Bench authors took Qwen2.5-Coder-7B-Instruct and fine-tuned it on about 600 website-building trajectories that DeepSeek-V3 produced inside Bolt, keeping only good-looking sites. So it already speaks Bolt's format, which makes it a fair small baseline. Everything runs on two H200 GPUs on the school cluster. The first GPU holds the 32B tester and the 7B generator; the second holds the 72B memory model and the embedding model. No paid API is used. We run two tasks in parallel, about twelve minutes each, and so far we have used about 470 GPU-hours.</a:t>
             </a:r>
           </a:p>
         </p:txBody>
@@ -1658,7 +1658,7 @@
           <a:lstStyle/>
           <a:p>
             <a:r>
-              <a:t>Same task, a solar dashboard. Without memory, the model imports a chart library that is not installed, so the page shows only an error and every test fails. This is the most common way the 7B model scores zero. With memory, the prompt carried a short working code example, and every test passed.</a:t>
+              <a:t>Here is what failure actually looks like. Same task, a solar dashboard. Without memory, the model imports a chart library that is not installed. The page shows only this error, so every test fails and the task scores zero. This is the most common way the 7B model gets zero. With the final memory, the prompt carried a short code example from an earlier site that worked; the model built all three views and every test passed. The numbered boxes are drawn by the tester to name what it can click.</a:t>
             </a:r>
           </a:p>
         </p:txBody>
@@ -3456,7 +3456,7 @@
                           </a:solidFill>
                           <a:latin typeface="Arial"/>
                         </a:rPr>
-                        <a:t>—</a:t>
+                        <a:t>Original order: lower than whole-file (vue-router came back)</a:t>
                       </a:r>
                     </a:p>
                   </a:txBody>
@@ -3478,7 +3478,7 @@
                           </a:solidFill>
                           <a:latin typeface="Arial"/>
                         </a:rPr>
-                        <a:t>Seed 11: +7.4; seed 29: +5.5</a:t>
+                        <a:t>35.2%, +7.1; seed 11 +7.4; seed 29 +5.5</a:t>
                       </a:r>
                     </a:p>
                   </a:txBody>
@@ -3751,7 +3751,7 @@
                 <a:ea typeface="Georgia" pitchFamily="18" charset="-122"/>
                 <a:cs typeface="Georgia" pitchFamily="18" charset="-120"/>
               </a:rPr>
-              <a:t>Accuracy rises from 28.5% to 40.0%</a:t>
+              <a:t>Accuracy rises from 28.5% to 35–40%</a:t>
             </a:r>
             <a:endParaRPr lang="en-US" sz="3000" dirty="0"/>
           </a:p>
@@ -4117,7 +4117,7 @@
                 <a:ea typeface="Arial" pitchFamily="34" charset="-122"/>
                 <a:cs typeface="Arial" pitchFamily="34" charset="-120"/>
               </a:rPr>
-              <a:t>Paired by task: +11.5 points (95% CI 6.0 to 16.9). Wins 54, losses 24, ties 23.</a:t>
+              <a:t>Whole-file: +11.5 points (95% CI 6.0 to 16.9), wins 54 / losses 24. Fragments (final method): 35.2%, +7.1 (0.9 to 13.1), 20 zero-score tasks.</a:t>
             </a:r>
             <a:endParaRPr lang="en-US" sz="1500" dirty="0"/>
           </a:p>
@@ -4907,7 +4907,7 @@
                 <a:ea typeface="Georgia" pitchFamily="18" charset="-122"/>
                 <a:cs typeface="Georgia" pitchFamily="18" charset="-120"/>
               </a:rPr>
-              <a:t>A whole-file example caused blank sites; checked fragments fixed it</a:t>
+              <a:t>Fragments removed blank scaffolds in shuffled orders</a:t>
             </a:r>
             <a:endParaRPr lang="en-US" sz="3000" dirty="0"/>
           </a:p>
@@ -5937,7 +5937,7 @@
                 <a:ea typeface="Arial" pitchFamily="34" charset="-122"/>
                 <a:cs typeface="Arial" pitchFamily="34" charset="-120"/>
               </a:rPr>
-              <a:t>Method was tuned on the same 101 tasks (checked on 2 new orders)</a:t>
+              <a:t>Method tuned on the same 101 tasks; in the original order fragments (35.2%) trail whole-file (40.0%)</a:t>
             </a:r>
             <a:endParaRPr lang="en-US" sz="1500" dirty="0"/>
           </a:p>
@@ -6026,7 +6026,7 @@
                 <a:ea typeface="Arial" pitchFamily="34" charset="-122"/>
                 <a:cs typeface="Arial" pitchFamily="34" charset="-120"/>
               </a:rPr>
-              <a:t>Fragments in the original order: 16 Oct</a:t>
+              <a:t>Seed 47 and interleaved orders: about 17–18 Oct</a:t>
             </a:r>
             <a:endParaRPr lang="en-US" sz="1500" dirty="0"/>
           </a:p>
@@ -6047,7 +6047,7 @@
                 <a:ea typeface="Arial" pitchFamily="34" charset="-122"/>
                 <a:cs typeface="Arial" pitchFamily="34" charset="-120"/>
               </a:rPr>
-              <a:t>Two more orders and fixed code prefix: by 18 Oct</a:t>
+              <a:t>Fixed code prefix: after seed 47</a:t>
             </a:r>
             <a:endParaRPr lang="en-US" sz="1500" dirty="0"/>
           </a:p>
@@ -6661,7 +6661,7 @@
                 <a:ea typeface="Arial" pitchFamily="34" charset="-122"/>
                 <a:cs typeface="Arial" pitchFamily="34" charset="-120"/>
               </a:rPr>
-              <a:t>28.5% → 40.0% · most of the gain comes from memory</a:t>
+              <a:t>28.5% → 35–40% · most of the gain comes from memory</a:t>
             </a:r>
             <a:endParaRPr lang="en-US" sz="1700" dirty="0"/>
           </a:p>
@@ -10712,7 +10712,7 @@
                 <a:ea typeface="Arial" pitchFamily="34" charset="-122"/>
                 <a:cs typeface="Arial" pitchFamily="34" charset="-120"/>
               </a:rPr>
-              <a:t>Fragments in the original order (ready 16 Oct)</a:t>
+              <a:t>Fragments in the original order: 35.2% (done 16 Oct)</a:t>
             </a:r>
             <a:endParaRPr lang="en-US" sz="1500" dirty="0"/>
           </a:p>
@@ -10801,7 +10801,7 @@
                 <a:ea typeface="Arial" pitchFamily="34" charset="-122"/>
                 <a:cs typeface="Arial" pitchFamily="34" charset="-120"/>
               </a:rPr>
-              <a:t>Fragments, original order: 16 Oct morning</a:t>
+              <a:t>Seed 47: about 60/101 on 16 Oct</a:t>
             </a:r>
             <a:endParaRPr lang="en-US" sz="1500" dirty="0"/>
           </a:p>

</xml_diff>

<commit_message>
Frame fragments as robust-across-orders final method; update V11 slide 11 and speaker notes
</commit_message>
<xml_diff>
--- a/docs/reports/group_meeting_deck_2026-10-16-en-v11/V11-Long-term memory for a small website generator.pptx
+++ b/docs/reports/group_meeting_deck_2026-10-16-en-v11/V11-Long-term memory for a small website generator.pptx
@@ -471,7 +471,7 @@
           <a:lstStyle/>
           <a:p>
             <a:r>
-              <a:t>We tried many versions, but they fall into three families, and from now on I only use these three names. Text memory gives the model lessons written as text; its last version adds a checklist. The text piles up and the small model ignores it: 30.9 percent. Code memory keeps the checklist and adds short code examples from our own working sites: this is the big jump, to 40 percent. The final version changes only how examples are chosen: only checked fragments, never a whole file, which matters when the task order changes. The last row is an ablation: the checklist alone, with memory turned off, helps only a little.</a:t>
+              <a:t>We tried many versions, but they fall into three families, and from now on I only use these three names. Text memory gives the model lessons written as text; its last version adds a checklist. The text piles up and the small model ignores it: 30.9 percent. Code memory keeps the checklist and adds short code examples from our own working sites: this is the big jump, to 40 percent. The final version shows only checked fragments, never a whole file. It reaches 35.2 percent in the original order, lower than the whole-file version, but it removed the blank-site failure in the shuffled orders. We chose it for robustness across orders, not for the top score. The last row is an ablation: the checklist alone, with memory turned off, helps only a little.</a:t>
             </a:r>
           </a:p>
         </p:txBody>
@@ -639,7 +639,7 @@
           <a:lstStyle/>
           <a:p>
             <a:r>
-              <a:t>This is the learning curve, in execution order. Text memory, in orange, starts high and then falls below No Memory. Code memory, in blue, keeps its lead to the end. So the gain grows with experience, it is not only an early boost.</a:t>
+              <a:t>This is the learning curve, in execution order. Text memory, in orange, starts high and then falls below No Memory. Both code memories, blue for whole-file and green for fragments, stay above No Memory to the end. So the gain is not only an early boost.</a:t>
             </a:r>
           </a:p>
         </p:txBody>
@@ -725,7 +725,7 @@
           <a:lstStyle/>
           <a:p>
             <a:r>
-              <a:t>The ablation adds one part at a time. The checklist alone adds 3.4 points, and this is not significant. Adding memory on top adds 8.1 points, and this is significant. So most of the gain comes from memory.</a:t>
+              <a:t>The ablation adds one part at a time. The checklist alone adds 3.4 points, and its confidence interval includes zero. Adding memory on top adds 8.1 points, and that interval excludes zero. So most of the gain comes from memory.</a:t>
             </a:r>
           </a:p>
         </p:txBody>
@@ -812,7 +812,7 @@
           <a:p>
             <a:r>
               <a:rPr dirty="0"/>
-              <a:t>With memory, the task order matters, because each task can only use what came before it. We tried two shuffled orders. With whole-file code memory the gain dropped to about four and a half points. The reason: one code example was a whole file, and the model copied it as a finished answer, returning the empty starter project. In the fragment version every example is a short checked fragment. Blank sites go to zero, and the gain is 7.4 points on seed 11, which is significant, and 5.5 on seed 29. The chart shows the gap staying near or above zero.</a:t>
+              <a:t>With memory, the task order matters, because each task can only use what came before it. We tried two shuffled orders. With whole-file code memory the gain dropped to about four and a half points. The reason: one code example was a whole file, and the model copied it as a finished answer, returning the empty starter project. In the fragment version every example is a short checked fragment. Blank sites go to zero, and the gain is 7.4 points on seed 11, with an interval that excludes zero, and 5.5 on seed 29. In the original order, though, fragments stopped the missing vue-router package less reliably, so neither form wins in every order.</a:t>
             </a:r>
           </a:p>
         </p:txBody>
@@ -893,7 +893,7 @@
           <a:lstStyle/>
           <a:p>
             <a:r>
-              <a:t>Some limits. Each order has one run, as in the original paper. The gain is in features, not in look. We used one model and one tool, and the method was developed on this benchmark. Next: the last runs finish this weekend, the 32B generator after that, and the thesis draft goes to my supervisor on Monday.</a:t>
+              <a:t>Some limits. Each order has one run, as in the original paper. The gain is in features, not in look. We used one model and one tool, and the method was developed on this benchmark. In the original order the fragment version trails the whole-file version. Next: seed 47 and the interleaved order, then the fixed-code control, and the thesis draft goes to my supervisor on Monday.</a:t>
             </a:r>
           </a:p>
         </p:txBody>
@@ -1066,7 +1066,7 @@
           <a:lstStyle/>
           <a:p>
             <a:r>
-              <a:t>To sum up: for a small model, memory should give code, not advice. Accuracy rises from 28.5 to 40 percent, and most of the gain comes from memory. Thank you.</a:t>
+              <a:t>To sum up: for a small model, memory should give code, not advice. Accuracy rises from 28.5 percent to between 35 and 40 percent, depending on the form of the code examples, and most of the gain comes from memory. Thank you.</a:t>
             </a:r>
           </a:p>
         </p:txBody>
@@ -1491,7 +1491,7 @@
           <a:lstStyle/>
           <a:p>
             <a:r>
-              <a:t>This slide shows the size of the study. Each run builds all 101 websites. We have eleven full runs: about one thousand one hundred websites and seven thousand checks. No Memory was run in three task orders, to measure how much the baseline itself varies. The remaining runs now use two lanes in parallel, so they finish this weekend; a stronger 32B generator follows.</a:t>
+              <a:t>This slide shows the size of the study. Each run builds all 101 websites. We have eleven full runs: about one thousand one hundred websites and seven thousand checks. No Memory was run in three task orders, to measure how much the baseline itself varies. The fragment version in the original order finished this morning. Seed 47 is about sixty percent done; the interleaved order and the fixed-code control follow.</a:t>
             </a:r>
           </a:p>
         </p:txBody>
@@ -3434,7 +3434,7 @@
                           </a:solidFill>
                           <a:latin typeface="Arial"/>
                         </a:rPr>
-                        <a:t>Final method: only checked fragments</a:t>
+                        <a:t>Final method: only checked fragments; chosen for robustness across orders, not top score</a:t>
                       </a:r>
                     </a:p>
                   </a:txBody>

</xml_diff>

<commit_message>
PPT V14 = V13 + final-method manifest result, short notes; restore V11 snapshot overwritten by mistake
</commit_message>
<xml_diff>
--- a/docs/reports/group_meeting_deck_2026-10-16-en-v11/V11-Long-term memory for a small website generator.pptx
+++ b/docs/reports/group_meeting_deck_2026-10-16-en-v11/V11-Long-term memory for a small website generator.pptx
@@ -471,7 +471,7 @@
           <a:lstStyle/>
           <a:p>
             <a:r>
-              <a:t>We tried many versions, but they fall into three families, and from now on I only use these three names. Text memory gives the model lessons written as text; its last version adds a checklist. The text piles up and the small model ignores it: 30.9 percent. Code memory keeps the checklist and adds short code examples from our own working sites: this is the big jump, to 40 percent. The final version shows only checked fragments, never a whole file. It reaches 35.2 percent in the original order, lower than the whole-file version, but it removed the blank-site failure in the shuffled orders. We chose it for robustness across orders, not for the top score. The last row is an ablation: the checklist alone, with memory turned off, helps only a little.</a:t>
+              <a:t>Our versions fall into three families. Text memory gives lessons as text; the small model mostly ignores them: 30.9 percent. Code memory adds short code examples from our own working sites: 40 percent. The final version uses only checked fragments, never whole files. And the checklist alone, without memory, helps only a little.</a:t>
             </a:r>
           </a:p>
         </p:txBody>
@@ -553,7 +553,7 @@
           <a:p>
             <a:r>
               <a:rPr dirty="0"/>
-              <a:t>The main result. Without memory: 28.5 percent and 30 zero-score tasks. With whole-file code memory: 40 percent and 13. Paired by task, the gain is 11.5 points, and the 95 percent confidence interval, 6 to 16.9, does not include zero. The final method with fragments reaches 35.2 percent, a gain of 7.1 points with interval 0.9 to 13.1, lower than whole-file in this order because vue-router imports came back.</a:t>
+              <a:t>The main result. Without memory: 28.5 percent and 30 zero-score tasks. With whole-file code memory: 40 percent and 13. Paired by task, the gain is 11.5 points, and the 95 percent confidence interval, 6 to 16.9, does not include zero.</a:t>
             </a:r>
           </a:p>
         </p:txBody>
@@ -639,7 +639,7 @@
           <a:lstStyle/>
           <a:p>
             <a:r>
-              <a:t>This is the learning curve, in execution order. Text memory, in orange, starts high and then falls below No Memory. Both code memories, blue for whole-file and green for fragments, stay above No Memory to the end. So the gain is not only an early boost.</a:t>
+              <a:t>This is the learning curve, in execution order. Text memory, in orange, starts high and then falls below No Memory. Code memory, in blue, keeps its lead to the end. So the gain grows with experience, it is not only an early boost.</a:t>
             </a:r>
           </a:p>
         </p:txBody>
@@ -725,7 +725,7 @@
           <a:lstStyle/>
           <a:p>
             <a:r>
-              <a:t>The ablation adds one part at a time. The checklist alone adds 3.4 points, and its confidence interval includes zero. Adding memory on top adds 8.1 points, and that interval excludes zero. So most of the gain comes from memory.</a:t>
+              <a:t>The ablation adds one part at a time. The checklist alone adds 3.4 points, and its interval includes zero. Adding memory on top adds 8.1 points, and its interval excludes zero. So most of the gain comes from memory.</a:t>
             </a:r>
           </a:p>
         </p:txBody>
@@ -812,7 +812,7 @@
           <a:p>
             <a:r>
               <a:rPr dirty="0"/>
-              <a:t>With memory, the task order matters, because each task can only use what came before it. We tried two shuffled orders. With whole-file code memory the gain dropped to about four and a half points. The reason: one code example was a whole file, and the model copied it as a finished answer, returning the empty starter project. In the fragment version every example is a short checked fragment. Blank sites go to zero, and the gain is 7.4 points on seed 11, with an interval that excludes zero, and 5.5 on seed 29. In the original order, though, fragments stopped the missing vue-router package less reliably, so neither form wins in every order.</a:t>
+              <a:t>With memory, order matters, because each task only sees earlier ones. In two shuffled orders, whole-file code memory gained only about 4.5 points: one whole-file example was copied as a finished answer, giving the empty starter project. With fragments only, the gain is 7.4 points on seed 11, where the interval excludes zero, and 5.5 on seed 29.</a:t>
             </a:r>
           </a:p>
         </p:txBody>
@@ -893,7 +893,7 @@
           <a:lstStyle/>
           <a:p>
             <a:r>
-              <a:t>Some limits. Each order has one run, as in the original paper. The gain is in features, not in look. We used one model and one tool, and the method was developed on this benchmark. In the original order the fragment version trails the whole-file version. Next: seed 47 and the interleaved order, then the fixed-code control, and the thesis draft goes to my supervisor on Monday.</a:t>
+              <a:t>Some limits. Each order has one run, as in the original paper. The gain is in features, not in look. We used one model and one tool, and the method was developed on this benchmark. Next: the last runs finish this weekend, the 32B generator after that, and the thesis draft goes to my supervisor on Monday.</a:t>
             </a:r>
           </a:p>
         </p:txBody>
@@ -1066,7 +1066,7 @@
           <a:lstStyle/>
           <a:p>
             <a:r>
-              <a:t>To sum up: for a small model, memory should give code, not advice. Accuracy rises from 28.5 percent to between 35 and 40 percent, depending on the form of the code examples, and most of the gain comes from memory. Thank you.</a:t>
+              <a:t>To sum up: for a small model, memory should give code, not advice. Accuracy rises from 28.5 to 40 percent, and most of the gain comes from memory. Thank you.</a:t>
             </a:r>
           </a:p>
         </p:txBody>
@@ -1410,7 +1410,7 @@
           <a:lstStyle/>
           <a:p>
             <a:r>
-              <a:t>Before the results, a word on the models and compute. The generator is WebGen-LM-7B. It is not a general Qwen model: the WebGen-Bench authors took Qwen2.5-Coder-7B-Instruct and fine-tuned it on about 600 website-building trajectories that DeepSeek-V3 produced inside Bolt, keeping only good-looking sites. So it already speaks Bolt's format, which makes it a fair small baseline. Everything runs on two H200 GPUs on the school cluster. The first GPU holds the 32B tester and the 7B generator; the second holds the 72B memory model and the embedding model. No paid API is used. We run two tasks in parallel, about twelve minutes each, and so far we have used about 470 GPU-hours.</a:t>
+              <a:t>The generator is WebGen-LM-7B: Qwen2.5-Coder-7B fine-tuned by the benchmark authors on Bolt trajectories, so it already knows Bolt's format. Everything is self-hosted on two H200 GPUs on the school cluster, with no paid API. One task takes about twelve minutes with memory.</a:t>
             </a:r>
           </a:p>
         </p:txBody>
@@ -1491,7 +1491,7 @@
           <a:lstStyle/>
           <a:p>
             <a:r>
-              <a:t>This slide shows the size of the study. Each run builds all 101 websites. We have eleven full runs: about one thousand one hundred websites and seven thousand checks. No Memory was run in three task orders, to measure how much the baseline itself varies. The fragment version in the original order finished this morning. Seed 47 is about sixty percent done; the interleaved order and the fixed-code control follow.</a:t>
+              <a:t>This slide shows the size of the study. Each run builds all 101 websites. We have eleven full runs: about one thousand one hundred websites and seven thousand checks. No Memory was run in three task orders, to measure how much the baseline itself varies. The remaining runs now use two lanes in parallel, so they finish this weekend; a stronger 32B generator follows.</a:t>
             </a:r>
           </a:p>
         </p:txBody>
@@ -1658,7 +1658,7 @@
           <a:lstStyle/>
           <a:p>
             <a:r>
-              <a:t>Here is what failure actually looks like. Same task, a solar dashboard. Without memory, the model imports a chart library that is not installed. The page shows only this error, so every test fails and the task scores zero. This is the most common way the 7B model gets zero. With the final memory, the prompt carried a short code example from an earlier site that worked; the model built all three views and every test passed. The numbered boxes are drawn by the tester to name what it can click.</a:t>
+              <a:t>Same task, a solar dashboard. Without memory, the model imports a chart library that is not installed, so the page shows only an error and every test fails. This is the most common way the 7B model scores zero. With memory, the prompt carried a short working code example, and every test passed.</a:t>
             </a:r>
           </a:p>
         </p:txBody>
@@ -3434,7 +3434,7 @@
                           </a:solidFill>
                           <a:latin typeface="Arial"/>
                         </a:rPr>
-                        <a:t>Final method: only checked fragments; chosen for robustness across orders, not top score</a:t>
+                        <a:t>Final method: only checked fragments</a:t>
                       </a:r>
                     </a:p>
                   </a:txBody>
@@ -3456,7 +3456,7 @@
                           </a:solidFill>
                           <a:latin typeface="Arial"/>
                         </a:rPr>
-                        <a:t>Original order: lower than whole-file (vue-router came back)</a:t>
+                        <a:t>—</a:t>
                       </a:r>
                     </a:p>
                   </a:txBody>
@@ -3478,7 +3478,7 @@
                           </a:solidFill>
                           <a:latin typeface="Arial"/>
                         </a:rPr>
-                        <a:t>35.2%, +7.1; seed 11 +7.4; seed 29 +5.5</a:t>
+                        <a:t>Seed 11: +7.4; seed 29: +5.5</a:t>
                       </a:r>
                     </a:p>
                   </a:txBody>
@@ -3751,7 +3751,7 @@
                 <a:ea typeface="Georgia" pitchFamily="18" charset="-122"/>
                 <a:cs typeface="Georgia" pitchFamily="18" charset="-120"/>
               </a:rPr>
-              <a:t>Accuracy rises from 28.5% to 35–40%</a:t>
+              <a:t>Accuracy rises from 28.5% to 40.0%</a:t>
             </a:r>
             <a:endParaRPr lang="en-US" sz="3000" dirty="0"/>
           </a:p>
@@ -4117,7 +4117,7 @@
                 <a:ea typeface="Arial" pitchFamily="34" charset="-122"/>
                 <a:cs typeface="Arial" pitchFamily="34" charset="-120"/>
               </a:rPr>
-              <a:t>Whole-file: +11.5 points (95% CI 6.0 to 16.9), wins 54 / losses 24. Fragments (final method): 35.2%, +7.1 (0.9 to 13.1), 20 zero-score tasks.</a:t>
+              <a:t>Paired by task: +11.5 points (95% CI 6.0 to 16.9). Wins 54, losses 24, ties 23.</a:t>
             </a:r>
             <a:endParaRPr lang="en-US" sz="1500" dirty="0"/>
           </a:p>
@@ -4907,7 +4907,7 @@
                 <a:ea typeface="Georgia" pitchFamily="18" charset="-122"/>
                 <a:cs typeface="Georgia" pitchFamily="18" charset="-120"/>
               </a:rPr>
-              <a:t>Fragments removed blank scaffolds in shuffled orders</a:t>
+              <a:t>A whole-file example caused blank sites; checked fragments fixed it</a:t>
             </a:r>
             <a:endParaRPr lang="en-US" sz="3000" dirty="0"/>
           </a:p>
@@ -5937,7 +5937,7 @@
                 <a:ea typeface="Arial" pitchFamily="34" charset="-122"/>
                 <a:cs typeface="Arial" pitchFamily="34" charset="-120"/>
               </a:rPr>
-              <a:t>Method tuned on the same 101 tasks; in the original order fragments (35.2%) trail whole-file (40.0%)</a:t>
+              <a:t>Method was tuned on the same 101 tasks (checked on 2 new orders)</a:t>
             </a:r>
             <a:endParaRPr lang="en-US" sz="1500" dirty="0"/>
           </a:p>
@@ -6026,7 +6026,7 @@
                 <a:ea typeface="Arial" pitchFamily="34" charset="-122"/>
                 <a:cs typeface="Arial" pitchFamily="34" charset="-120"/>
               </a:rPr>
-              <a:t>Seed 47 and interleaved orders: about 17–18 Oct</a:t>
+              <a:t>Fragments in the original order: 16 Oct</a:t>
             </a:r>
             <a:endParaRPr lang="en-US" sz="1500" dirty="0"/>
           </a:p>
@@ -6047,7 +6047,7 @@
                 <a:ea typeface="Arial" pitchFamily="34" charset="-122"/>
                 <a:cs typeface="Arial" pitchFamily="34" charset="-120"/>
               </a:rPr>
-              <a:t>Fixed code prefix: after seed 47</a:t>
+              <a:t>Two more orders and fixed code prefix: by 18 Oct</a:t>
             </a:r>
             <a:endParaRPr lang="en-US" sz="1500" dirty="0"/>
           </a:p>
@@ -6661,7 +6661,7 @@
                 <a:ea typeface="Arial" pitchFamily="34" charset="-122"/>
                 <a:cs typeface="Arial" pitchFamily="34" charset="-120"/>
               </a:rPr>
-              <a:t>28.5% → 35–40% · most of the gain comes from memory</a:t>
+              <a:t>28.5% → 40.0% · most of the gain comes from memory</a:t>
             </a:r>
             <a:endParaRPr lang="en-US" sz="1700" dirty="0"/>
           </a:p>
@@ -10712,7 +10712,7 @@
                 <a:ea typeface="Arial" pitchFamily="34" charset="-122"/>
                 <a:cs typeface="Arial" pitchFamily="34" charset="-120"/>
               </a:rPr>
-              <a:t>Fragments in the original order: 35.2% (done 16 Oct)</a:t>
+              <a:t>Fragments in the original order (ready 16 Oct)</a:t>
             </a:r>
             <a:endParaRPr lang="en-US" sz="1500" dirty="0"/>
           </a:p>
@@ -10801,7 +10801,7 @@
                 <a:ea typeface="Arial" pitchFamily="34" charset="-122"/>
                 <a:cs typeface="Arial" pitchFamily="34" charset="-120"/>
               </a:rPr>
-              <a:t>Seed 47: about 60/101 on 16 Oct</a:t>
+              <a:t>Fragments, original order: 16 Oct morning</a:t>
             </a:r>
             <a:endParaRPr lang="en-US" sz="1500" dirty="0"/>
           </a:p>

</xml_diff>